<commit_message>
Add isolated AI tuning experiment
Co-authored-by: Copilot <223556219+Copilot@users.noreply.github.com>
</commit_message>
<xml_diff>
--- a/presentacion/Presentacion_Diagnostico_IA_OpenMetadata_MSP_Final.pptx
+++ b/presentacion/Presentacion_Diagnostico_IA_OpenMetadata_MSP_Final.pptx
@@ -6266,7 +6266,7 @@
                 </a:solidFill>
                 <a:latin typeface="Segoe UI"/>
               </a:rPr>
-              <a:t>DBA/MSP aprueba, prueba y mide el índice.</a:t>
+              <a:t>DBA/MSP revisa y autoriza las pruebas o cambios.</a:t>
             </a:r>
           </a:p>
         </p:txBody>
@@ -7433,7 +7433,7 @@
                 </a:solidFill>
                 <a:latin typeface="Segoe UI"/>
               </a:rPr>
-              <a:t>EXPLAIN (ANALYZE, BUFFERS, FORMAT JSON).</a:t>
+              <a:t>EXPLAIN JSON, cinco muestras por escenario.</a:t>
             </a:r>
           </a:p>
         </p:txBody>
@@ -7603,7 +7603,7 @@
                 </a:solidFill>
                 <a:latin typeface="Segoe UI"/>
               </a:rPr>
-              <a:t>Problema buscado: </a:t>
+              <a:t>Observación: </a:t>
             </a:r>
             <a:r>
               <a:rPr b="0" sz="1200">
@@ -7612,7 +7612,7 @@
                 </a:solidFill>
                 <a:latin typeface="Segoe UI"/>
               </a:rPr>
-              <a:t>Recorrido amplio y trabajo de ordenamiento.</a:t>
+              <a:t>El modelo identifica cuellos desde el plan, sin solución sugerida.</a:t>
             </a:r>
           </a:p>
           <a:p>
@@ -7649,7 +7649,7 @@
                 </a:solidFill>
                 <a:latin typeface="Segoe UI"/>
               </a:rPr>
-              <a:t>Plan JSON y columnas leídas desde information_schema.</a:t>
+              <a:t>Plan JSON, columnas e índices actuales.</a:t>
             </a:r>
           </a:p>
           <a:p>
@@ -7819,7 +7819,7 @@
               </a:defRPr>
             </a:pPr>
             <a:r>
-              <a:t>Del diagnóstico a una mejora medida</a:t>
+              <a:t>Del diagnóstico a una hipótesis verificable</a:t>
             </a:r>
           </a:p>
         </p:txBody>
@@ -7961,7 +7961,7 @@
                 </a:solidFill>
                 <a:latin typeface="Segoe UI"/>
               </a:rPr>
-              <a:t>SQL, plan observado y columnas reales de la tabla.</a:t>
+              <a:t>SQL, plan, esquema e índices actuales.</a:t>
             </a:r>
           </a:p>
           <a:p>
@@ -8026,7 +8026,7 @@
                 </a:solidFill>
                 <a:latin typeface="Segoe UI"/>
               </a:rPr>
-              <a:t>DDL candidato: </a:t>
+              <a:t>Estrategias: </a:t>
             </a:r>
             <a:r>
               <a:rPr b="0" sz="1200">
@@ -8035,7 +8035,7 @@
                 </a:solidFill>
                 <a:latin typeface="Segoe UI"/>
               </a:rPr>
-              <a:t>CREATE INDEX ON transacciones (cuenta_id, fecha_hora DESC).</a:t>
+              <a:t>Propone alternativas justificadas o recomienda no cambiar.</a:t>
             </a:r>
           </a:p>
           <a:p>
@@ -8063,7 +8063,7 @@
                 </a:solidFill>
                 <a:latin typeface="Segoe UI"/>
               </a:rPr>
-              <a:t>Reescritura: </a:t>
+              <a:t>Límites: </a:t>
             </a:r>
             <a:r>
               <a:rPr b="0" sz="1200">
@@ -8072,7 +8072,7 @@
                 </a:solidFill>
                 <a:latin typeface="Segoe UI"/>
               </a:rPr>
-              <a:t>Propone alternativas solo si preservan el resultado.</a:t>
+              <a:t>Declara evidencia faltante y beneficios/riesgos esperados.</a:t>
             </a:r>
           </a:p>
         </p:txBody>
@@ -8205,7 +8205,7 @@
                 </a:solidFill>
                 <a:latin typeface="Segoe UI"/>
               </a:rPr>
-              <a:t>Comparar: </a:t>
+              <a:t>Contrastar: </a:t>
             </a:r>
             <a:r>
               <a:rPr b="0" sz="1200">
@@ -8214,7 +8214,7 @@
                 </a:solidFill>
                 <a:latin typeface="Segoe UI"/>
               </a:rPr>
-              <a:t>Nodos del plan, filas, buffers y mediana de ejecución.</a:t>
+              <a:t>Verificar la recomendación con el plan y los índices reales.</a:t>
             </a:r>
           </a:p>
           <a:p>
@@ -8242,7 +8242,7 @@
                 </a:solidFill>
                 <a:latin typeface="Segoe UI"/>
               </a:rPr>
-              <a:t>Revisar costo: </a:t>
+              <a:t>Probar: </a:t>
             </a:r>
             <a:r>
               <a:rPr b="0" sz="1200">
@@ -8251,7 +8251,7 @@
                 </a:solidFill>
                 <a:latin typeface="Segoe UI"/>
               </a:rPr>
-              <a:t>Espacio, escritura adicional, mantenimiento y bloqueos.</a:t>
+              <a:t>Tres candidatos predefinidos en copias temporales.</a:t>
             </a:r>
           </a:p>
           <a:p>
@@ -8279,7 +8279,7 @@
                 </a:solidFill>
                 <a:latin typeface="Segoe UI"/>
               </a:rPr>
-              <a:t>Aplicar: </a:t>
+              <a:t>Medir: </a:t>
             </a:r>
             <a:r>
               <a:rPr b="0" sz="1200">
@@ -8288,7 +8288,7 @@
                 </a:solidFill>
                 <a:latin typeface="Segoe UI"/>
               </a:rPr>
-              <a:t>El lab ejecuta un DDL fijo; nunca SQL libre de la IA.</a:t>
+              <a:t>Calienta y alterna: compara filas, buffers y medianas.</a:t>
             </a:r>
           </a:p>
           <a:p>
@@ -8316,7 +8316,7 @@
                 </a:solidFill>
                 <a:latin typeface="Segoe UI"/>
               </a:rPr>
-              <a:t>Operar: </a:t>
+              <a:t>Límite: </a:t>
             </a:r>
             <a:r>
               <a:rPr b="0" sz="1200">
@@ -8325,7 +8325,7 @@
                 </a:solidFill>
                 <a:latin typeface="Segoe UI"/>
               </a:rPr>
-              <a:t>Desplegar con aprobación, monitorizar y tener rollback.</a:t>
+              <a:t>El índice temporal se elimina; prueba solo en laboratorio.</a:t>
             </a:r>
           </a:p>
         </p:txBody>
@@ -9023,7 +9023,7 @@
                 </a:solidFill>
                 <a:latin typeface="Segoe UI"/>
               </a:rPr>
-              <a:t>Comando: </a:t>
+              <a:t>Hipótesis: </a:t>
             </a:r>
             <a:r>
               <a:rPr b="0" sz="1100">
@@ -9032,7 +9032,7 @@
                 </a:solidFill>
                 <a:latin typeface="Segoe UI"/>
               </a:rPr>
-              <a:t>py .\scripts\ai_db_tuning.py --use-openmetadata --apply-demo-index</a:t>
+              <a:t>El modelo sugirió un índice sobre cuenta_id.</a:t>
             </a:r>
           </a:p>
           <a:p>
@@ -9060,7 +9060,7 @@
                 </a:solidFill>
                 <a:latin typeface="Segoe UI"/>
               </a:rPr>
-              <a:t>Contrastar: </a:t>
+              <a:t>Resultado: </a:t>
             </a:r>
             <a:r>
               <a:rPr b="0" sz="1100">
@@ -9069,7 +9069,7 @@
                 </a:solidFill>
                 <a:latin typeface="Segoe UI"/>
               </a:rPr>
-              <a:t>Plan posterior, buffers y tiempo mediano.</a:t>
+              <a:t>Misma salida; mediana observada: 8,905 a 0,085 ms.</a:t>
             </a:r>
           </a:p>
           <a:p>
@@ -9097,7 +9097,7 @@
                 </a:solidFill>
                 <a:latin typeface="Segoe UI"/>
               </a:rPr>
-              <a:t>Cerrar: </a:t>
+              <a:t>Cautela: </a:t>
             </a:r>
             <a:r>
               <a:rPr b="0" sz="1100">
@@ -9106,7 +9106,7 @@
                 </a:solidFill>
                 <a:latin typeface="Segoe UI"/>
               </a:rPr>
-              <a:t>MSP formaliza aprobación, SLO y aprendizaje.</a:t>
+              <a:t>Lecturas locales 1.906 a 6; resultado no garantizado.</a:t>
             </a:r>
           </a:p>
         </p:txBody>

</xml_diff>